<commit_message>
Align complete pathway narration and all 17 slide timings to five minutes
</commit_message>
<xml_diff>
--- a/submission/PathwayAI_Complete_Pathway_Backup.pptx
+++ b/submission/PathwayAI_Complete_Pathway_Backup.pptx
@@ -3278,7 +3278,7 @@
   <p:clrMapOvr>
     <a:masterClrMapping/>
   </p:clrMapOvr>
-  <p:transition advClick="1" advTm="18000"/>
+  <p:transition advClick="1" advTm="25000"/>
 </p:sld>
 </file>
 
@@ -3466,7 +3466,7 @@
   <p:clrMapOvr>
     <a:masterClrMapping/>
   </p:clrMapOvr>
-  <p:transition advClick="1" advTm="18000"/>
+  <p:transition advClick="1" advTm="15000"/>
 </p:sld>
 </file>
 
@@ -3842,7 +3842,7 @@
   <p:clrMapOvr>
     <a:masterClrMapping/>
   </p:clrMapOvr>
-  <p:transition advClick="1" advTm="20000"/>
+  <p:transition advClick="1" advTm="16000"/>
 </p:sld>
 </file>
 
@@ -4218,7 +4218,7 @@
   <p:clrMapOvr>
     <a:masterClrMapping/>
   </p:clrMapOvr>
-  <p:transition advClick="1" advTm="20000"/>
+  <p:transition advClick="1" advTm="18000"/>
 </p:sld>
 </file>
 
@@ -4406,7 +4406,7 @@
   <p:clrMapOvr>
     <a:masterClrMapping/>
   </p:clrMapOvr>
-  <p:transition advClick="1" advTm="18000"/>
+  <p:transition advClick="1" advTm="15000"/>
 </p:sld>
 </file>
 
@@ -4594,7 +4594,7 @@
   <p:clrMapOvr>
     <a:masterClrMapping/>
   </p:clrMapOvr>
-  <p:transition advClick="1" advTm="20000"/>
+  <p:transition advClick="1" advTm="23000"/>
 </p:sld>
 </file>
 
@@ -4782,7 +4782,7 @@
   <p:clrMapOvr>
     <a:masterClrMapping/>
   </p:clrMapOvr>
-  <p:transition advClick="1" advTm="15000"/>
+  <p:transition advClick="1" advTm="27000"/>
 </p:sld>
 </file>
 
@@ -5346,7 +5346,7 @@
   <p:clrMapOvr>
     <a:masterClrMapping/>
   </p:clrMapOvr>
-  <p:transition advClick="1" advTm="22000"/>
+  <p:transition advClick="1" advTm="24000"/>
 </p:sld>
 </file>
 
@@ -5534,7 +5534,7 @@
   <p:clrMapOvr>
     <a:masterClrMapping/>
   </p:clrMapOvr>
-  <p:transition advClick="1" advTm="12000"/>
+  <p:transition advClick="1" advTm="10000"/>
 </p:sld>
 </file>
 
@@ -5722,7 +5722,7 @@
   <p:clrMapOvr>
     <a:masterClrMapping/>
   </p:clrMapOvr>
-  <p:transition advClick="1" advTm="24000"/>
+  <p:transition advClick="1" advTm="22000"/>
 </p:sld>
 </file>
 
@@ -5910,7 +5910,7 @@
   <p:clrMapOvr>
     <a:masterClrMapping/>
   </p:clrMapOvr>
-  <p:transition advClick="1" advTm="16000"/>
+  <p:transition advClick="1" advTm="14000"/>
 </p:sld>
 </file>
 
@@ -6098,7 +6098,7 @@
   <p:clrMapOvr>
     <a:masterClrMapping/>
   </p:clrMapOvr>
-  <p:transition advClick="1" advTm="14000"/>
+  <p:transition advClick="1" advTm="12000"/>
 </p:sld>
 </file>
 
@@ -6286,7 +6286,7 @@
   <p:clrMapOvr>
     <a:masterClrMapping/>
   </p:clrMapOvr>
-  <p:transition advClick="1" advTm="26000"/>
+  <p:transition advClick="1" advTm="22000"/>
 </p:sld>
 </file>
 

</xml_diff>